<commit_message>
Apply security-review findings: Excel formula injection, localhost binding, redaction of tool results
Independent security review of the branch: no High; two Medium, one Low.
Exported workbooks (checklist, confirmed values, bundle, ledger) now pass
through pii.excel_safe, which prefixes formula-leading string cells so
request text or uploaded cells cannot become live formulas (covers pandas
3 'str' dtype). Streamlit binds to localhost only and the DB reset needs
an explicit confirmation. History-QA tool results and the request/item
texts sent for drafts, checks and follow-up questions are redacted with
the same PII masking used for extraction. Three regression tests (58).

Co-Authored-By: Claude Fable 5.1 <noreply@anthropic.com>
Claude-Session: https://claude.ai/code/session_01JoDziuss8iV2Vzqkd34EF8
</commit_message>
<xml_diff>
--- a/app/docs/발표자료_EBS_요구자료대응에이전트.pptx
+++ b/app/docs/발표자료_EBS_요구자료대응에이전트.pptx
@@ -124,14 +124,14 @@
   <p:extLst>
     <p:ext uri="{521415D9-36F7-43E2-AB2F-B90AF26B5E84}">
       <p14:sectionLst xmlns:p14="http://schemas.microsoft.com/office/powerpoint/2010/main">
-        <p14:section name="개요" id="{e2ee04eb-d44f-80f0-cd3d-73ec3240d160}">
+        <p14:section name="개요" id="{78dcbfc2-c3cc-d460-eaf3-80cd5d9488d3}">
           <p14:sldIdLst>
             <p14:sldId id="256"/>
             <p14:sldId id="257"/>
             <p14:sldId id="258"/>
           </p14:sldIdLst>
         </p14:section>
-        <p14:section name="해결" id="{4c57d932-fc2b-eaed-9163-2d163325a020}">
+        <p14:section name="해결" id="{4fb9e2bd-54fa-144c-ffc1-9e78b2cfcfda}">
           <p14:sldIdLst>
             <p14:sldId id="259"/>
             <p14:sldId id="260"/>
@@ -139,7 +139,7 @@
             <p14:sldId id="262"/>
           </p14:sldIdLst>
         </p14:section>
-        <p14:section name="시연" id="{99afd00f-22fc-5ee6-7caf-1cea6ebd7e58}">
+        <p14:section name="시연" id="{e1e06635-4c47-ef58-2f42-ca8d4b68f5f2}">
           <p14:sldIdLst>
             <p14:sldId id="263"/>
             <p14:sldId id="264"/>
@@ -149,14 +149,14 @@
             <p14:sldId id="268"/>
           </p14:sldIdLst>
         </p14:section>
-        <p14:section name="구현" id="{db75f334-db58-ed06-a492-84be1e9e6821}">
+        <p14:section name="구현" id="{38fdaddf-ea81-1d3c-8502-3c177348218f}">
           <p14:sldIdLst>
             <p14:sldId id="269"/>
             <p14:sldId id="270"/>
             <p14:sldId id="271"/>
           </p14:sldIdLst>
         </p14:section>
-        <p14:section name="마무리" id="{33a92a68-2533-4850-d7fe-f52c0c322e8a}">
+        <p14:section name="마무리" id="{a6109435-db4b-0245-5c86-ecea5b905c81}">
           <p14:sldIdLst>
             <p14:sldId id="272"/>
             <p14:sldId id="273"/>
@@ -8206,7 +8206,7 @@
                   <a:schemeClr val="tx1"/>
                 </a:solidFill>
               </a:rPr>
-              <a:t>run_checks.py: ruff → pytest 55건 → 추출 품질 점검(규칙/Claude) → 화면 흐름 ①~⑧  ·  make_submission_zip.py  ·  capture_screens.py</a:t>
+              <a:t>run_checks.py: ruff → pytest 58건 → 추출 품질 점검(규칙/Claude) → 화면 흐름 ①~⑧  ·  make_submission_zip.py  ·  capture_screens.py</a:t>
             </a:r>
             <a:endParaRPr lang="en-US" sz="1050" dirty="0"/>
           </a:p>
@@ -8898,7 +8898,7 @@
       </p:sp>
       <p:sp>
         <p:nvSpPr>
-          <p:cNvPr id="7" name="stat-pytest 단위 테스트 통과 (모듈 테스트 45 + 코드 리뷰 회귀 10)"/>
+          <p:cNvPr id="7" name="stat-pytest 단위 테스트 통과 (모듈 45 + 코드 리뷰 회귀 10 + 보안 3)"/>
           <p:cNvSpPr txBox="1"/>
           <p:nvPr/>
         </p:nvSpPr>
@@ -8926,7 +8926,7 @@
                   <a:schemeClr val="accent1"/>
                 </a:solidFill>
               </a:rPr>
-              <a:t>55</a:t>
+              <a:t>58</a:t>
             </a:r>
             <a:endParaRPr lang="en-US" sz="4000" dirty="0"/>
           </a:p>
@@ -8934,7 +8934,7 @@
       </p:sp>
       <p:sp>
         <p:nvSpPr>
-          <p:cNvPr id="8" name="stat-label-pytest 단위 테스트 통과 (모듈 테스트 45 + 코드 리뷰 회귀 10)"/>
+          <p:cNvPr id="8" name="stat-label-pytest 단위 테스트 통과 (모듈 45 + 코드 리뷰 회귀 10 + 보안 3)"/>
           <p:cNvSpPr txBox="1"/>
           <p:nvPr/>
         </p:nvSpPr>
@@ -8976,7 +8976,7 @@
                   <a:schemeClr val="accent5"/>
                 </a:solidFill>
               </a:rPr>
-              <a:t>(모듈 테스트 45 + 코드 리뷰 회귀 10)</a:t>
+              <a:t>(모듈 45 + 코드 리뷰 회귀 10 + 보안 3)</a:t>
             </a:r>
             <a:endParaRPr lang="en-US" sz="1200" dirty="0"/>
           </a:p>

</xml_diff>